<commit_message>
Polish Stroop generator docs
Co-authored-by: ShubhamP37048 <229071278+ShubhamP37048@users.noreply.github.com>
</commit_message>
<xml_diff>
--- a/docs/stroop-test-30-slides.pptx
+++ b/docs/stroop-test-30-slides.pptx
@@ -3173,7 +3173,7 @@
             <a:avLst/>
           </a:prstGeom>
           <a:noFill/>
-          <a:ln>
+          <a:ln w="12700">
             <a:solidFill>
               <a:srgbClr val="EBEBEB"/>
             </a:solidFill>
@@ -3391,7 +3391,7 @@
             <a:avLst/>
           </a:prstGeom>
           <a:noFill/>
-          <a:ln>
+          <a:ln w="12700">
             <a:solidFill>
               <a:srgbClr val="EBEBEB"/>
             </a:solidFill>
@@ -3609,7 +3609,7 @@
             <a:avLst/>
           </a:prstGeom>
           <a:noFill/>
-          <a:ln>
+          <a:ln w="12700">
             <a:solidFill>
               <a:srgbClr val="EBEBEB"/>
             </a:solidFill>
@@ -3827,7 +3827,7 @@
             <a:avLst/>
           </a:prstGeom>
           <a:noFill/>
-          <a:ln>
+          <a:ln w="12700">
             <a:solidFill>
               <a:srgbClr val="EBEBEB"/>
             </a:solidFill>
@@ -4045,7 +4045,7 @@
             <a:avLst/>
           </a:prstGeom>
           <a:noFill/>
-          <a:ln>
+          <a:ln w="12700">
             <a:solidFill>
               <a:srgbClr val="EBEBEB"/>
             </a:solidFill>
@@ -4263,7 +4263,7 @@
             <a:avLst/>
           </a:prstGeom>
           <a:noFill/>
-          <a:ln>
+          <a:ln w="12700">
             <a:solidFill>
               <a:srgbClr val="EBEBEB"/>
             </a:solidFill>
@@ -4481,7 +4481,7 @@
             <a:avLst/>
           </a:prstGeom>
           <a:noFill/>
-          <a:ln>
+          <a:ln w="12700">
             <a:solidFill>
               <a:srgbClr val="EBEBEB"/>
             </a:solidFill>
@@ -4699,7 +4699,7 @@
             <a:avLst/>
           </a:prstGeom>
           <a:noFill/>
-          <a:ln>
+          <a:ln w="12700">
             <a:solidFill>
               <a:srgbClr val="EBEBEB"/>
             </a:solidFill>
@@ -4905,7 +4905,7 @@
             <a:avLst/>
           </a:prstGeom>
           <a:noFill/>
-          <a:ln>
+          <a:ln w="12700">
             <a:solidFill>
               <a:srgbClr val="EBEBEB"/>
             </a:solidFill>
@@ -5088,7 +5088,7 @@
             <a:avLst/>
           </a:prstGeom>
           <a:noFill/>
-          <a:ln>
+          <a:ln w="12700">
             <a:solidFill>
               <a:srgbClr val="EBEBEB"/>
             </a:solidFill>
@@ -5446,7 +5446,7 @@
             <a:avLst/>
           </a:prstGeom>
           <a:noFill/>
-          <a:ln>
+          <a:ln w="12700">
             <a:solidFill>
               <a:srgbClr val="EBEBEB"/>
             </a:solidFill>
@@ -5629,7 +5629,7 @@
             <a:avLst/>
           </a:prstGeom>
           <a:noFill/>
-          <a:ln>
+          <a:ln w="12700">
             <a:solidFill>
               <a:srgbClr val="EBEBEB"/>
             </a:solidFill>
@@ -5812,7 +5812,7 @@
             <a:avLst/>
           </a:prstGeom>
           <a:noFill/>
-          <a:ln>
+          <a:ln w="12700">
             <a:solidFill>
               <a:srgbClr val="EBEBEB"/>
             </a:solidFill>
@@ -5995,7 +5995,7 @@
             <a:avLst/>
           </a:prstGeom>
           <a:noFill/>
-          <a:ln>
+          <a:ln w="12700">
             <a:solidFill>
               <a:srgbClr val="EBEBEB"/>
             </a:solidFill>
@@ -6178,7 +6178,7 @@
             <a:avLst/>
           </a:prstGeom>
           <a:noFill/>
-          <a:ln>
+          <a:ln w="12700">
             <a:solidFill>
               <a:srgbClr val="EBEBEB"/>
             </a:solidFill>
@@ -6489,7 +6489,7 @@
             <a:avLst/>
           </a:prstGeom>
           <a:noFill/>
-          <a:ln>
+          <a:ln w="12700">
             <a:solidFill>
               <a:srgbClr val="EBEBEB"/>
             </a:solidFill>
@@ -6707,7 +6707,7 @@
             <a:avLst/>
           </a:prstGeom>
           <a:noFill/>
-          <a:ln>
+          <a:ln w="12700">
             <a:solidFill>
               <a:srgbClr val="EBEBEB"/>
             </a:solidFill>
@@ -7065,7 +7065,7 @@
             <a:avLst/>
           </a:prstGeom>
           <a:noFill/>
-          <a:ln>
+          <a:ln w="12700">
             <a:solidFill>
               <a:srgbClr val="EBEBEB"/>
             </a:solidFill>
@@ -7283,7 +7283,7 @@
             <a:avLst/>
           </a:prstGeom>
           <a:noFill/>
-          <a:ln>
+          <a:ln w="12700">
             <a:solidFill>
               <a:srgbClr val="EBEBEB"/>
             </a:solidFill>
@@ -7466,7 +7466,7 @@
             <a:avLst/>
           </a:prstGeom>
           <a:noFill/>
-          <a:ln>
+          <a:ln w="12700">
             <a:solidFill>
               <a:srgbClr val="EBEBEB"/>
             </a:solidFill>
@@ -7684,7 +7684,7 @@
             <a:avLst/>
           </a:prstGeom>
           <a:noFill/>
-          <a:ln>
+          <a:ln w="12700">
             <a:solidFill>
               <a:srgbClr val="EBEBEB"/>
             </a:solidFill>
@@ -8135,7 +8135,7 @@
             <a:avLst/>
           </a:prstGeom>
           <a:noFill/>
-          <a:ln>
+          <a:ln w="12700">
             <a:solidFill>
               <a:srgbClr val="EBEBEB"/>
             </a:solidFill>
@@ -8283,7 +8283,7 @@
             <a:avLst/>
           </a:prstGeom>
           <a:noFill/>
-          <a:ln>
+          <a:ln w="12700">
             <a:solidFill>
               <a:srgbClr val="EBEBEB"/>
             </a:solidFill>
@@ -8431,7 +8431,7 @@
             <a:avLst/>
           </a:prstGeom>
           <a:noFill/>
-          <a:ln>
+          <a:ln w="12700">
             <a:solidFill>
               <a:srgbClr val="EBEBEB"/>
             </a:solidFill>
@@ -8579,7 +8579,7 @@
             <a:avLst/>
           </a:prstGeom>
           <a:noFill/>
-          <a:ln>
+          <a:ln w="12700">
             <a:solidFill>
               <a:srgbClr val="EBEBEB"/>
             </a:solidFill>
@@ -9007,7 +9007,7 @@
             <a:avLst/>
           </a:prstGeom>
           <a:noFill/>
-          <a:ln>
+          <a:ln w="12700">
             <a:solidFill>
               <a:srgbClr val="EBEBEB"/>
             </a:solidFill>
@@ -9155,7 +9155,7 @@
             <a:avLst/>
           </a:prstGeom>
           <a:noFill/>
-          <a:ln>
+          <a:ln w="12700">
             <a:solidFill>
               <a:srgbClr val="EBEBEB"/>
             </a:solidFill>
@@ -9466,7 +9466,7 @@
             <a:avLst/>
           </a:prstGeom>
           <a:noFill/>
-          <a:ln>
+          <a:ln w="12700">
             <a:solidFill>
               <a:srgbClr val="EBEBEB"/>
             </a:solidFill>
@@ -9684,7 +9684,7 @@
             <a:avLst/>
           </a:prstGeom>
           <a:noFill/>
-          <a:ln>
+          <a:ln w="12700">
             <a:solidFill>
               <a:srgbClr val="EBEBEB"/>
             </a:solidFill>
@@ -9902,7 +9902,7 @@
             <a:avLst/>
           </a:prstGeom>
           <a:noFill/>
-          <a:ln>
+          <a:ln w="12700">
             <a:solidFill>
               <a:srgbClr val="EBEBEB"/>
             </a:solidFill>
@@ -10120,7 +10120,7 @@
             <a:avLst/>
           </a:prstGeom>
           <a:noFill/>
-          <a:ln>
+          <a:ln w="12700">
             <a:solidFill>
               <a:srgbClr val="EBEBEB"/>
             </a:solidFill>
@@ -10338,7 +10338,7 @@
             <a:avLst/>
           </a:prstGeom>
           <a:noFill/>
-          <a:ln>
+          <a:ln w="12700">
             <a:solidFill>
               <a:srgbClr val="EBEBEB"/>
             </a:solidFill>
@@ -10556,7 +10556,7 @@
             <a:avLst/>
           </a:prstGeom>
           <a:noFill/>
-          <a:ln>
+          <a:ln w="12700">
             <a:solidFill>
               <a:srgbClr val="EBEBEB"/>
             </a:solidFill>
@@ -10774,7 +10774,7 @@
             <a:avLst/>
           </a:prstGeom>
           <a:noFill/>
-          <a:ln>
+          <a:ln w="12700">
             <a:solidFill>
               <a:srgbClr val="EBEBEB"/>
             </a:solidFill>
@@ -11085,7 +11085,7 @@
             <a:avLst/>
           </a:prstGeom>
           <a:noFill/>
-          <a:ln>
+          <a:ln w="12700">
             <a:solidFill>
               <a:srgbClr val="EBEBEB"/>
             </a:solidFill>
@@ -11338,7 +11338,7 @@
             <a:avLst/>
           </a:prstGeom>
           <a:noFill/>
-          <a:ln>
+          <a:ln w="12700">
             <a:solidFill>
               <a:srgbClr val="EBEBEB"/>
             </a:solidFill>
@@ -11556,7 +11556,7 @@
             <a:avLst/>
           </a:prstGeom>
           <a:noFill/>
-          <a:ln>
+          <a:ln w="12700">
             <a:solidFill>
               <a:srgbClr val="EBEBEB"/>
             </a:solidFill>
@@ -11634,7 +11634,7 @@
             <a:avLst/>
           </a:prstGeom>
           <a:noFill/>
-          <a:ln>
+          <a:ln w="12700">
             <a:solidFill>
               <a:srgbClr val="EBEBEB"/>
             </a:solidFill>
@@ -11852,7 +11852,7 @@
             <a:avLst/>
           </a:prstGeom>
           <a:noFill/>
-          <a:ln>
+          <a:ln w="12700">
             <a:solidFill>
               <a:srgbClr val="EBEBEB"/>
             </a:solidFill>
@@ -12105,7 +12105,7 @@
             <a:avLst/>
           </a:prstGeom>
           <a:noFill/>
-          <a:ln>
+          <a:ln w="12700">
             <a:solidFill>
               <a:srgbClr val="EBEBEB"/>
             </a:solidFill>
@@ -12358,7 +12358,7 @@
             <a:avLst/>
           </a:prstGeom>
           <a:noFill/>
-          <a:ln>
+          <a:ln w="12700">
             <a:solidFill>
               <a:srgbClr val="EBEBEB"/>
             </a:solidFill>
@@ -12669,7 +12669,7 @@
             <a:avLst/>
           </a:prstGeom>
           <a:noFill/>
-          <a:ln>
+          <a:ln w="12700">
             <a:solidFill>
               <a:srgbClr val="EBEBEB"/>
             </a:solidFill>
@@ -12887,7 +12887,7 @@
             <a:avLst/>
           </a:prstGeom>
           <a:noFill/>
-          <a:ln>
+          <a:ln w="12700">
             <a:solidFill>
               <a:srgbClr val="EBEBEB"/>
             </a:solidFill>
@@ -13000,7 +13000,7 @@
             <a:avLst/>
           </a:prstGeom>
           <a:noFill/>
-          <a:ln>
+          <a:ln w="12700">
             <a:solidFill>
               <a:srgbClr val="EBEBEB"/>
             </a:solidFill>
@@ -13218,7 +13218,7 @@
             <a:avLst/>
           </a:prstGeom>
           <a:noFill/>
-          <a:ln>
+          <a:ln w="12700">
             <a:solidFill>
               <a:srgbClr val="EBEBEB"/>
             </a:solidFill>
@@ -13506,7 +13506,7 @@
             <a:avLst/>
           </a:prstGeom>
           <a:noFill/>
-          <a:ln>
+          <a:ln w="12700">
             <a:solidFill>
               <a:srgbClr val="EBEBEB"/>
             </a:solidFill>
@@ -13794,7 +13794,7 @@
             <a:avLst/>
           </a:prstGeom>
           <a:noFill/>
-          <a:ln>
+          <a:ln w="12700">
             <a:solidFill>
               <a:srgbClr val="EBEBEB"/>
             </a:solidFill>
@@ -14105,7 +14105,7 @@
             <a:avLst/>
           </a:prstGeom>
           <a:noFill/>
-          <a:ln>
+          <a:ln w="12700">
             <a:solidFill>
               <a:srgbClr val="EBEBEB"/>
             </a:solidFill>
@@ -14463,7 +14463,7 @@
             <a:avLst/>
           </a:prstGeom>
           <a:noFill/>
-          <a:ln>
+          <a:ln w="12700">
             <a:solidFill>
               <a:srgbClr val="EBEBEB"/>
             </a:solidFill>
@@ -14646,7 +14646,7 @@
             <a:avLst/>
           </a:prstGeom>
           <a:noFill/>
-          <a:ln>
+          <a:ln w="12700">
             <a:solidFill>
               <a:srgbClr val="EBEBEB"/>
             </a:solidFill>
@@ -14829,7 +14829,7 @@
             <a:avLst/>
           </a:prstGeom>
           <a:noFill/>
-          <a:ln>
+          <a:ln w="12700">
             <a:solidFill>
               <a:srgbClr val="EBEBEB"/>
             </a:solidFill>
@@ -15012,7 +15012,7 @@
             <a:avLst/>
           </a:prstGeom>
           <a:noFill/>
-          <a:ln>
+          <a:ln w="12700">
             <a:solidFill>
               <a:srgbClr val="EBEBEB"/>
             </a:solidFill>
@@ -15195,7 +15195,7 @@
             <a:avLst/>
           </a:prstGeom>
           <a:noFill/>
-          <a:ln>
+          <a:ln w="12700">
             <a:solidFill>
               <a:srgbClr val="EBEBEB"/>
             </a:solidFill>
@@ -15553,7 +15553,7 @@
             <a:avLst/>
           </a:prstGeom>
           <a:noFill/>
-          <a:ln>
+          <a:ln w="12700">
             <a:solidFill>
               <a:srgbClr val="EBEBEB"/>
             </a:solidFill>
@@ -15864,7 +15864,7 @@
             <a:avLst/>
           </a:prstGeom>
           <a:noFill/>
-          <a:ln>
+          <a:ln w="12700">
             <a:solidFill>
               <a:srgbClr val="EBEBEB"/>
             </a:solidFill>
@@ -16082,7 +16082,7 @@
             <a:avLst/>
           </a:prstGeom>
           <a:noFill/>
-          <a:ln>
+          <a:ln w="12700">
             <a:solidFill>
               <a:srgbClr val="EBEBEB"/>
             </a:solidFill>
@@ -16265,7 +16265,7 @@
             <a:avLst/>
           </a:prstGeom>
           <a:noFill/>
-          <a:ln>
+          <a:ln w="12700">
             <a:solidFill>
               <a:srgbClr val="EBEBEB"/>
             </a:solidFill>
@@ -16483,7 +16483,7 @@
             <a:avLst/>
           </a:prstGeom>
           <a:noFill/>
-          <a:ln>
+          <a:ln w="12700">
             <a:solidFill>
               <a:srgbClr val="EBEBEB"/>
             </a:solidFill>
@@ -16666,7 +16666,7 @@
             <a:avLst/>
           </a:prstGeom>
           <a:noFill/>
-          <a:ln>
+          <a:ln w="12700">
             <a:solidFill>
               <a:srgbClr val="EBEBEB"/>
             </a:solidFill>
@@ -16884,7 +16884,7 @@
             <a:avLst/>
           </a:prstGeom>
           <a:noFill/>
-          <a:ln>
+          <a:ln w="12700">
             <a:solidFill>
               <a:srgbClr val="EBEBEB"/>
             </a:solidFill>
@@ -17230,7 +17230,7 @@
             <a:avLst/>
           </a:prstGeom>
           <a:noFill/>
-          <a:ln>
+          <a:ln w="12700">
             <a:solidFill>
               <a:srgbClr val="EBEBEB"/>
             </a:solidFill>
@@ -17378,7 +17378,7 @@
             <a:avLst/>
           </a:prstGeom>
           <a:noFill/>
-          <a:ln>
+          <a:ln w="12700">
             <a:solidFill>
               <a:srgbClr val="EBEBEB"/>
             </a:solidFill>
@@ -17526,7 +17526,7 @@
             <a:avLst/>
           </a:prstGeom>
           <a:noFill/>
-          <a:ln>
+          <a:ln w="12700">
             <a:solidFill>
               <a:srgbClr val="EBEBEB"/>
             </a:solidFill>
@@ -17674,7 +17674,7 @@
             <a:avLst/>
           </a:prstGeom>
           <a:noFill/>
-          <a:ln>
+          <a:ln w="12700">
             <a:solidFill>
               <a:srgbClr val="EBEBEB"/>
             </a:solidFill>
@@ -18102,7 +18102,7 @@
             <a:avLst/>
           </a:prstGeom>
           <a:noFill/>
-          <a:ln>
+          <a:ln w="12700">
             <a:solidFill>
               <a:srgbClr val="EBEBEB"/>
             </a:solidFill>
@@ -18250,7 +18250,7 @@
             <a:avLst/>
           </a:prstGeom>
           <a:noFill/>
-          <a:ln>
+          <a:ln w="12700">
             <a:solidFill>
               <a:srgbClr val="EBEBEB"/>
             </a:solidFill>
@@ -18398,7 +18398,7 @@
             <a:avLst/>
           </a:prstGeom>
           <a:noFill/>
-          <a:ln>
+          <a:ln w="12700">
             <a:solidFill>
               <a:srgbClr val="EBEBEB"/>
             </a:solidFill>
@@ -18709,7 +18709,7 @@
             <a:avLst/>
           </a:prstGeom>
           <a:noFill/>
-          <a:ln>
+          <a:ln w="12700">
             <a:solidFill>
               <a:srgbClr val="EBEBEB"/>
             </a:solidFill>
@@ -18927,7 +18927,7 @@
             <a:avLst/>
           </a:prstGeom>
           <a:noFill/>
-          <a:ln>
+          <a:ln w="12700">
             <a:solidFill>
               <a:srgbClr val="EBEBEB"/>
             </a:solidFill>
@@ -19145,7 +19145,7 @@
             <a:avLst/>
           </a:prstGeom>
           <a:noFill/>
-          <a:ln>
+          <a:ln w="12700">
             <a:solidFill>
               <a:srgbClr val="EBEBEB"/>
             </a:solidFill>
@@ -19363,7 +19363,7 @@
             <a:avLst/>
           </a:prstGeom>
           <a:noFill/>
-          <a:ln>
+          <a:ln w="12700">
             <a:solidFill>
               <a:srgbClr val="EBEBEB"/>
             </a:solidFill>
@@ -19581,7 +19581,7 @@
             <a:avLst/>
           </a:prstGeom>
           <a:noFill/>
-          <a:ln>
+          <a:ln w="12700">
             <a:solidFill>
               <a:srgbClr val="EBEBEB"/>
             </a:solidFill>
@@ -19799,7 +19799,7 @@
             <a:avLst/>
           </a:prstGeom>
           <a:noFill/>
-          <a:ln>
+          <a:ln w="12700">
             <a:solidFill>
               <a:srgbClr val="EBEBEB"/>
             </a:solidFill>
@@ -20017,7 +20017,7 @@
             <a:avLst/>
           </a:prstGeom>
           <a:noFill/>
-          <a:ln>
+          <a:ln w="12700">
             <a:solidFill>
               <a:srgbClr val="EBEBEB"/>
             </a:solidFill>
@@ -20433,7 +20433,7 @@
             <a:avLst/>
           </a:prstGeom>
           <a:noFill/>
-          <a:ln>
+          <a:ln w="12700">
             <a:solidFill>
               <a:srgbClr val="EBEBEB"/>
             </a:solidFill>
@@ -20686,7 +20686,7 @@
             <a:avLst/>
           </a:prstGeom>
           <a:noFill/>
-          <a:ln>
+          <a:ln w="12700">
             <a:solidFill>
               <a:srgbClr val="EBEBEB"/>
             </a:solidFill>
@@ -20939,7 +20939,7 @@
             <a:avLst/>
           </a:prstGeom>
           <a:noFill/>
-          <a:ln>
+          <a:ln w="12700">
             <a:solidFill>
               <a:srgbClr val="EBEBEB"/>
             </a:solidFill>
@@ -21192,7 +21192,7 @@
             <a:avLst/>
           </a:prstGeom>
           <a:noFill/>
-          <a:ln>
+          <a:ln w="12700">
             <a:solidFill>
               <a:srgbClr val="EBEBEB"/>
             </a:solidFill>
@@ -21410,7 +21410,7 @@
             <a:avLst/>
           </a:prstGeom>
           <a:noFill/>
-          <a:ln>
+          <a:ln w="12700">
             <a:solidFill>
               <a:srgbClr val="EBEBEB"/>
             </a:solidFill>
@@ -21488,7 +21488,7 @@
             <a:avLst/>
           </a:prstGeom>
           <a:noFill/>
-          <a:ln>
+          <a:ln w="12700">
             <a:solidFill>
               <a:srgbClr val="EBEBEB"/>
             </a:solidFill>
@@ -21706,7 +21706,7 @@
             <a:avLst/>
           </a:prstGeom>
           <a:noFill/>
-          <a:ln>
+          <a:ln w="12700">
             <a:solidFill>
               <a:srgbClr val="EBEBEB"/>
             </a:solidFill>
@@ -21947,7 +21947,7 @@
             <a:avLst/>
           </a:prstGeom>
           <a:noFill/>
-          <a:ln>
+          <a:ln w="12700">
             <a:solidFill>
               <a:srgbClr val="EBEBEB"/>
             </a:solidFill>
@@ -22165,7 +22165,7 @@
             <a:avLst/>
           </a:prstGeom>
           <a:noFill/>
-          <a:ln>
+          <a:ln w="12700">
             <a:solidFill>
               <a:srgbClr val="EBEBEB"/>
             </a:solidFill>
@@ -22243,7 +22243,7 @@
             <a:avLst/>
           </a:prstGeom>
           <a:noFill/>
-          <a:ln>
+          <a:ln w="12700">
             <a:solidFill>
               <a:srgbClr val="EBEBEB"/>
             </a:solidFill>
@@ -22461,7 +22461,7 @@
             <a:avLst/>
           </a:prstGeom>
           <a:noFill/>
-          <a:ln>
+          <a:ln w="12700">
             <a:solidFill>
               <a:srgbClr val="EBEBEB"/>
             </a:solidFill>
@@ -22714,7 +22714,7 @@
             <a:avLst/>
           </a:prstGeom>
           <a:noFill/>
-          <a:ln>
+          <a:ln w="12700">
             <a:solidFill>
               <a:srgbClr val="EBEBEB"/>
             </a:solidFill>
@@ -22967,7 +22967,7 @@
             <a:avLst/>
           </a:prstGeom>
           <a:noFill/>
-          <a:ln>
+          <a:ln w="12700">
             <a:solidFill>
               <a:srgbClr val="EBEBEB"/>
             </a:solidFill>
@@ -23220,7 +23220,7 @@
             <a:avLst/>
           </a:prstGeom>
           <a:noFill/>
-          <a:ln>
+          <a:ln w="12700">
             <a:solidFill>
               <a:srgbClr val="EBEBEB"/>
             </a:solidFill>
@@ -23531,7 +23531,7 @@
             <a:avLst/>
           </a:prstGeom>
           <a:noFill/>
-          <a:ln>
+          <a:ln w="12700">
             <a:solidFill>
               <a:srgbClr val="EBEBEB"/>
             </a:solidFill>
@@ -23749,7 +23749,7 @@
             <a:avLst/>
           </a:prstGeom>
           <a:noFill/>
-          <a:ln>
+          <a:ln w="12700">
             <a:solidFill>
               <a:srgbClr val="EBEBEB"/>
             </a:solidFill>
@@ -24037,7 +24037,7 @@
             <a:avLst/>
           </a:prstGeom>
           <a:noFill/>
-          <a:ln>
+          <a:ln w="12700">
             <a:solidFill>
               <a:srgbClr val="EBEBEB"/>
             </a:solidFill>
@@ -24325,7 +24325,7 @@
             <a:avLst/>
           </a:prstGeom>
           <a:noFill/>
-          <a:ln>
+          <a:ln w="12700">
             <a:solidFill>
               <a:srgbClr val="EBEBEB"/>
             </a:solidFill>
@@ -24613,7 +24613,7 @@
             <a:avLst/>
           </a:prstGeom>
           <a:noFill/>
-          <a:ln>
+          <a:ln w="12700">
             <a:solidFill>
               <a:srgbClr val="EBEBEB"/>
             </a:solidFill>
@@ -24831,7 +24831,7 @@
             <a:avLst/>
           </a:prstGeom>
           <a:noFill/>
-          <a:ln>
+          <a:ln w="12700">
             <a:solidFill>
               <a:srgbClr val="EBEBEB"/>
             </a:solidFill>
@@ -25142,7 +25142,7 @@
             <a:avLst/>
           </a:prstGeom>
           <a:noFill/>
-          <a:ln>
+          <a:ln w="12700">
             <a:solidFill>
               <a:srgbClr val="EBEBEB"/>
             </a:solidFill>
@@ -25325,7 +25325,7 @@
             <a:avLst/>
           </a:prstGeom>
           <a:noFill/>
-          <a:ln>
+          <a:ln w="12700">
             <a:solidFill>
               <a:srgbClr val="EBEBEB"/>
             </a:solidFill>
@@ -25508,7 +25508,7 @@
             <a:avLst/>
           </a:prstGeom>
           <a:noFill/>
-          <a:ln>
+          <a:ln w="12700">
             <a:solidFill>
               <a:srgbClr val="EBEBEB"/>
             </a:solidFill>
@@ -25691,7 +25691,7 @@
             <a:avLst/>
           </a:prstGeom>
           <a:noFill/>
-          <a:ln>
+          <a:ln w="12700">
             <a:solidFill>
               <a:srgbClr val="EBEBEB"/>
             </a:solidFill>
@@ -25874,7 +25874,7 @@
             <a:avLst/>
           </a:prstGeom>
           <a:noFill/>
-          <a:ln>
+          <a:ln w="12700">
             <a:solidFill>
               <a:srgbClr val="EBEBEB"/>
             </a:solidFill>
@@ -26232,7 +26232,7 @@
             <a:avLst/>
           </a:prstGeom>
           <a:noFill/>
-          <a:ln>
+          <a:ln w="12700">
             <a:solidFill>
               <a:srgbClr val="EBEBEB"/>
             </a:solidFill>
@@ -26415,7 +26415,7 @@
             <a:avLst/>
           </a:prstGeom>
           <a:noFill/>
-          <a:ln>
+          <a:ln w="12700">
             <a:solidFill>
               <a:srgbClr val="EBEBEB"/>
             </a:solidFill>
@@ -26726,7 +26726,7 @@
             <a:avLst/>
           </a:prstGeom>
           <a:noFill/>
-          <a:ln>
+          <a:ln w="12700">
             <a:solidFill>
               <a:srgbClr val="EBEBEB"/>
             </a:solidFill>
@@ -26944,7 +26944,7 @@
             <a:avLst/>
           </a:prstGeom>
           <a:noFill/>
-          <a:ln>
+          <a:ln w="12700">
             <a:solidFill>
               <a:srgbClr val="EBEBEB"/>
             </a:solidFill>
@@ -27127,7 +27127,7 @@
             <a:avLst/>
           </a:prstGeom>
           <a:noFill/>
-          <a:ln>
+          <a:ln w="12700">
             <a:solidFill>
               <a:srgbClr val="EBEBEB"/>
             </a:solidFill>
@@ -27345,7 +27345,7 @@
             <a:avLst/>
           </a:prstGeom>
           <a:noFill/>
-          <a:ln>
+          <a:ln w="12700">
             <a:solidFill>
               <a:srgbClr val="EBEBEB"/>
             </a:solidFill>
@@ -27528,7 +27528,7 @@
             <a:avLst/>
           </a:prstGeom>
           <a:noFill/>
-          <a:ln>
+          <a:ln w="12700">
             <a:solidFill>
               <a:srgbClr val="EBEBEB"/>
             </a:solidFill>
@@ -27746,7 +27746,7 @@
             <a:avLst/>
           </a:prstGeom>
           <a:noFill/>
-          <a:ln>
+          <a:ln w="12700">
             <a:solidFill>
               <a:srgbClr val="EBEBEB"/>
             </a:solidFill>
@@ -28092,7 +28092,7 @@
             <a:avLst/>
           </a:prstGeom>
           <a:noFill/>
-          <a:ln>
+          <a:ln w="12700">
             <a:solidFill>
               <a:srgbClr val="EBEBEB"/>
             </a:solidFill>
@@ -28240,7 +28240,7 @@
             <a:avLst/>
           </a:prstGeom>
           <a:noFill/>
-          <a:ln>
+          <a:ln w="12700">
             <a:solidFill>
               <a:srgbClr val="EBEBEB"/>
             </a:solidFill>
@@ -28388,7 +28388,7 @@
             <a:avLst/>
           </a:prstGeom>
           <a:noFill/>
-          <a:ln>
+          <a:ln w="12700">
             <a:solidFill>
               <a:srgbClr val="EBEBEB"/>
             </a:solidFill>
@@ -28816,7 +28816,7 @@
             <a:avLst/>
           </a:prstGeom>
           <a:noFill/>
-          <a:ln>
+          <a:ln w="12700">
             <a:solidFill>
               <a:srgbClr val="EBEBEB"/>
             </a:solidFill>
@@ -28964,7 +28964,7 @@
             <a:avLst/>
           </a:prstGeom>
           <a:noFill/>
-          <a:ln>
+          <a:ln w="12700">
             <a:solidFill>
               <a:srgbClr val="EBEBEB"/>
             </a:solidFill>
@@ -29112,7 +29112,7 @@
             <a:avLst/>
           </a:prstGeom>
           <a:noFill/>
-          <a:ln>
+          <a:ln w="12700">
             <a:solidFill>
               <a:srgbClr val="EBEBEB"/>
             </a:solidFill>
@@ -29260,7 +29260,7 @@
             <a:avLst/>
           </a:prstGeom>
           <a:noFill/>
-          <a:ln>
+          <a:ln w="12700">
             <a:solidFill>
               <a:srgbClr val="EBEBEB"/>
             </a:solidFill>
@@ -29571,7 +29571,7 @@
             <a:avLst/>
           </a:prstGeom>
           <a:noFill/>
-          <a:ln>
+          <a:ln w="12700">
             <a:solidFill>
               <a:srgbClr val="EBEBEB"/>
             </a:solidFill>
@@ -29789,7 +29789,7 @@
             <a:avLst/>
           </a:prstGeom>
           <a:noFill/>
-          <a:ln>
+          <a:ln w="12700">
             <a:solidFill>
               <a:srgbClr val="EBEBEB"/>
             </a:solidFill>
@@ -30007,7 +30007,7 @@
             <a:avLst/>
           </a:prstGeom>
           <a:noFill/>
-          <a:ln>
+          <a:ln w="12700">
             <a:solidFill>
               <a:srgbClr val="EBEBEB"/>
             </a:solidFill>
@@ -30225,7 +30225,7 @@
             <a:avLst/>
           </a:prstGeom>
           <a:noFill/>
-          <a:ln>
+          <a:ln w="12700">
             <a:solidFill>
               <a:srgbClr val="EBEBEB"/>
             </a:solidFill>
@@ -30443,7 +30443,7 @@
             <a:avLst/>
           </a:prstGeom>
           <a:noFill/>
-          <a:ln>
+          <a:ln w="12700">
             <a:solidFill>
               <a:srgbClr val="EBEBEB"/>
             </a:solidFill>
@@ -30661,7 +30661,7 @@
             <a:avLst/>
           </a:prstGeom>
           <a:noFill/>
-          <a:ln>
+          <a:ln w="12700">
             <a:solidFill>
               <a:srgbClr val="EBEBEB"/>
             </a:solidFill>
@@ -30879,7 +30879,7 @@
             <a:avLst/>
           </a:prstGeom>
           <a:noFill/>
-          <a:ln>
+          <a:ln w="12700">
             <a:solidFill>
               <a:srgbClr val="EBEBEB"/>
             </a:solidFill>
@@ -31190,7 +31190,7 @@
             <a:avLst/>
           </a:prstGeom>
           <a:noFill/>
-          <a:ln>
+          <a:ln w="12700">
             <a:solidFill>
               <a:srgbClr val="EBEBEB"/>
             </a:solidFill>
@@ -31408,7 +31408,7 @@
             <a:avLst/>
           </a:prstGeom>
           <a:noFill/>
-          <a:ln>
+          <a:ln w="12700">
             <a:solidFill>
               <a:srgbClr val="EBEBEB"/>
             </a:solidFill>
@@ -31661,7 +31661,7 @@
             <a:avLst/>
           </a:prstGeom>
           <a:noFill/>
-          <a:ln>
+          <a:ln w="12700">
             <a:solidFill>
               <a:srgbClr val="EBEBEB"/>
             </a:solidFill>
@@ -31914,7 +31914,7 @@
             <a:avLst/>
           </a:prstGeom>
           <a:noFill/>
-          <a:ln>
+          <a:ln w="12700">
             <a:solidFill>
               <a:srgbClr val="EBEBEB"/>
             </a:solidFill>
@@ -32167,7 +32167,7 @@
             <a:avLst/>
           </a:prstGeom>
           <a:noFill/>
-          <a:ln>
+          <a:ln w="12700">
             <a:solidFill>
               <a:srgbClr val="EBEBEB"/>
             </a:solidFill>
@@ -32420,7 +32420,7 @@
             <a:avLst/>
           </a:prstGeom>
           <a:noFill/>
-          <a:ln>
+          <a:ln w="12700">
             <a:solidFill>
               <a:srgbClr val="EBEBEB"/>
             </a:solidFill>
@@ -32638,7 +32638,7 @@
             <a:avLst/>
           </a:prstGeom>
           <a:noFill/>
-          <a:ln>
+          <a:ln w="12700">
             <a:solidFill>
               <a:srgbClr val="EBEBEB"/>
             </a:solidFill>
@@ -32949,7 +32949,7 @@
             <a:avLst/>
           </a:prstGeom>
           <a:noFill/>
-          <a:ln>
+          <a:ln w="12700">
             <a:solidFill>
               <a:srgbClr val="EBEBEB"/>
             </a:solidFill>
@@ -33237,7 +33237,7 @@
             <a:avLst/>
           </a:prstGeom>
           <a:noFill/>
-          <a:ln>
+          <a:ln w="12700">
             <a:solidFill>
               <a:srgbClr val="EBEBEB"/>
             </a:solidFill>
@@ -33525,7 +33525,7 @@
             <a:avLst/>
           </a:prstGeom>
           <a:noFill/>
-          <a:ln>
+          <a:ln w="12700">
             <a:solidFill>
               <a:srgbClr val="EBEBEB"/>
             </a:solidFill>
@@ -33743,7 +33743,7 @@
             <a:avLst/>
           </a:prstGeom>
           <a:noFill/>
-          <a:ln>
+          <a:ln w="12700">
             <a:solidFill>
               <a:srgbClr val="EBEBEB"/>
             </a:solidFill>
@@ -33856,7 +33856,7 @@
             <a:avLst/>
           </a:prstGeom>
           <a:noFill/>
-          <a:ln>
+          <a:ln w="12700">
             <a:solidFill>
               <a:srgbClr val="EBEBEB"/>
             </a:solidFill>
@@ -34074,7 +34074,7 @@
             <a:avLst/>
           </a:prstGeom>
           <a:noFill/>
-          <a:ln>
+          <a:ln w="12700">
             <a:solidFill>
               <a:srgbClr val="EBEBEB"/>
             </a:solidFill>
@@ -34385,7 +34385,7 @@
             <a:avLst/>
           </a:prstGeom>
           <a:noFill/>
-          <a:ln>
+          <a:ln w="12700">
             <a:solidFill>
               <a:srgbClr val="EBEBEB"/>
             </a:solidFill>
@@ -34568,7 +34568,7 @@
             <a:avLst/>
           </a:prstGeom>
           <a:noFill/>
-          <a:ln>
+          <a:ln w="12700">
             <a:solidFill>
               <a:srgbClr val="EBEBEB"/>
             </a:solidFill>
@@ -34751,7 +34751,7 @@
             <a:avLst/>
           </a:prstGeom>
           <a:noFill/>
-          <a:ln>
+          <a:ln w="12700">
             <a:solidFill>
               <a:srgbClr val="EBEBEB"/>
             </a:solidFill>
@@ -34934,7 +34934,7 @@
             <a:avLst/>
           </a:prstGeom>
           <a:noFill/>
-          <a:ln>
+          <a:ln w="12700">
             <a:solidFill>
               <a:srgbClr val="EBEBEB"/>
             </a:solidFill>
@@ -35292,7 +35292,7 @@
             <a:avLst/>
           </a:prstGeom>
           <a:noFill/>
-          <a:ln>
+          <a:ln w="12700">
             <a:solidFill>
               <a:srgbClr val="EBEBEB"/>
             </a:solidFill>
@@ -35475,7 +35475,7 @@
             <a:avLst/>
           </a:prstGeom>
           <a:noFill/>
-          <a:ln>
+          <a:ln w="12700">
             <a:solidFill>
               <a:srgbClr val="EBEBEB"/>
             </a:solidFill>
@@ -35658,7 +35658,7 @@
             <a:avLst/>
           </a:prstGeom>
           <a:noFill/>
-          <a:ln>
+          <a:ln w="12700">
             <a:solidFill>
               <a:srgbClr val="EBEBEB"/>
             </a:solidFill>
@@ -35969,7 +35969,7 @@
             <a:avLst/>
           </a:prstGeom>
           <a:noFill/>
-          <a:ln>
+          <a:ln w="12700">
             <a:solidFill>
               <a:srgbClr val="EBEBEB"/>
             </a:solidFill>
@@ -36187,7 +36187,7 @@
             <a:avLst/>
           </a:prstGeom>
           <a:noFill/>
-          <a:ln>
+          <a:ln w="12700">
             <a:solidFill>
               <a:srgbClr val="EBEBEB"/>
             </a:solidFill>
@@ -36370,7 +36370,7 @@
             <a:avLst/>
           </a:prstGeom>
           <a:noFill/>
-          <a:ln>
+          <a:ln w="12700">
             <a:solidFill>
               <a:srgbClr val="EBEBEB"/>
             </a:solidFill>
@@ -36588,7 +36588,7 @@
             <a:avLst/>
           </a:prstGeom>
           <a:noFill/>
-          <a:ln>
+          <a:ln w="12700">
             <a:solidFill>
               <a:srgbClr val="EBEBEB"/>
             </a:solidFill>
@@ -36771,7 +36771,7 @@
             <a:avLst/>
           </a:prstGeom>
           <a:noFill/>
-          <a:ln>
+          <a:ln w="12700">
             <a:solidFill>
               <a:srgbClr val="EBEBEB"/>
             </a:solidFill>
@@ -36989,7 +36989,7 @@
             <a:avLst/>
           </a:prstGeom>
           <a:noFill/>
-          <a:ln>
+          <a:ln w="12700">
             <a:solidFill>
               <a:srgbClr val="EBEBEB"/>
             </a:solidFill>
@@ -37405,7 +37405,7 @@
             <a:avLst/>
           </a:prstGeom>
           <a:noFill/>
-          <a:ln>
+          <a:ln w="12700">
             <a:solidFill>
               <a:srgbClr val="EBEBEB"/>
             </a:solidFill>
@@ -37693,7 +37693,7 @@
             <a:avLst/>
           </a:prstGeom>
           <a:noFill/>
-          <a:ln>
+          <a:ln w="12700">
             <a:solidFill>
               <a:srgbClr val="EBEBEB"/>
             </a:solidFill>
@@ -37911,7 +37911,7 @@
             <a:avLst/>
           </a:prstGeom>
           <a:noFill/>
-          <a:ln>
+          <a:ln w="12700">
             <a:solidFill>
               <a:srgbClr val="EBEBEB"/>
             </a:solidFill>
@@ -38024,7 +38024,7 @@
             <a:avLst/>
           </a:prstGeom>
           <a:noFill/>
-          <a:ln>
+          <a:ln w="12700">
             <a:solidFill>
               <a:srgbClr val="EBEBEB"/>
             </a:solidFill>
@@ -38242,7 +38242,7 @@
             <a:avLst/>
           </a:prstGeom>
           <a:noFill/>
-          <a:ln>
+          <a:ln w="12700">
             <a:solidFill>
               <a:srgbClr val="EBEBEB"/>
             </a:solidFill>
@@ -38355,7 +38355,7 @@
             <a:avLst/>
           </a:prstGeom>
           <a:noFill/>
-          <a:ln>
+          <a:ln w="12700">
             <a:solidFill>
               <a:srgbClr val="EBEBEB"/>
             </a:solidFill>
@@ -38573,7 +38573,7 @@
             <a:avLst/>
           </a:prstGeom>
           <a:noFill/>
-          <a:ln>
+          <a:ln w="12700">
             <a:solidFill>
               <a:srgbClr val="EBEBEB"/>
             </a:solidFill>
@@ -38849,7 +38849,7 @@
             <a:avLst/>
           </a:prstGeom>
           <a:noFill/>
-          <a:ln>
+          <a:ln w="12700">
             <a:solidFill>
               <a:srgbClr val="EBEBEB"/>
             </a:solidFill>
@@ -38997,7 +38997,7 @@
             <a:avLst/>
           </a:prstGeom>
           <a:noFill/>
-          <a:ln>
+          <a:ln w="12700">
             <a:solidFill>
               <a:srgbClr val="EBEBEB"/>
             </a:solidFill>
@@ -39425,7 +39425,7 @@
             <a:avLst/>
           </a:prstGeom>
           <a:noFill/>
-          <a:ln>
+          <a:ln w="12700">
             <a:solidFill>
               <a:srgbClr val="EBEBEB"/>
             </a:solidFill>
@@ -39573,7 +39573,7 @@
             <a:avLst/>
           </a:prstGeom>
           <a:noFill/>
-          <a:ln>
+          <a:ln w="12700">
             <a:solidFill>
               <a:srgbClr val="EBEBEB"/>
             </a:solidFill>
@@ -39721,7 +39721,7 @@
             <a:avLst/>
           </a:prstGeom>
           <a:noFill/>
-          <a:ln>
+          <a:ln w="12700">
             <a:solidFill>
               <a:srgbClr val="EBEBEB"/>
             </a:solidFill>
@@ -39869,7 +39869,7 @@
             <a:avLst/>
           </a:prstGeom>
           <a:noFill/>
-          <a:ln>
+          <a:ln w="12700">
             <a:solidFill>
               <a:srgbClr val="EBEBEB"/>
             </a:solidFill>
@@ -40355,7 +40355,7 @@
             <a:avLst/>
           </a:prstGeom>
           <a:noFill/>
-          <a:ln>
+          <a:ln w="12700">
             <a:solidFill>
               <a:srgbClr val="EBEBEB"/>
             </a:solidFill>
@@ -40538,7 +40538,7 @@
             <a:avLst/>
           </a:prstGeom>
           <a:noFill/>
-          <a:ln>
+          <a:ln w="12700">
             <a:solidFill>
               <a:srgbClr val="EBEBEB"/>
             </a:solidFill>
@@ -40721,7 +40721,7 @@
             <a:avLst/>
           </a:prstGeom>
           <a:noFill/>
-          <a:ln>
+          <a:ln w="12700">
             <a:solidFill>
               <a:srgbClr val="EBEBEB"/>
             </a:solidFill>
@@ -41079,7 +41079,7 @@
             <a:avLst/>
           </a:prstGeom>
           <a:noFill/>
-          <a:ln>
+          <a:ln w="12700">
             <a:solidFill>
               <a:srgbClr val="EBEBEB"/>
             </a:solidFill>
@@ -41262,7 +41262,7 @@
             <a:avLst/>
           </a:prstGeom>
           <a:noFill/>
-          <a:ln>
+          <a:ln w="12700">
             <a:solidFill>
               <a:srgbClr val="EBEBEB"/>
             </a:solidFill>
@@ -41445,7 +41445,7 @@
             <a:avLst/>
           </a:prstGeom>
           <a:noFill/>
-          <a:ln>
+          <a:ln w="12700">
             <a:solidFill>
               <a:srgbClr val="EBEBEB"/>
             </a:solidFill>
@@ -41628,7 +41628,7 @@
             <a:avLst/>
           </a:prstGeom>
           <a:noFill/>
-          <a:ln>
+          <a:ln w="12700">
             <a:solidFill>
               <a:srgbClr val="EBEBEB"/>
             </a:solidFill>
@@ -41939,7 +41939,7 @@
             <a:avLst/>
           </a:prstGeom>
           <a:noFill/>
-          <a:ln>
+          <a:ln w="12700">
             <a:solidFill>
               <a:srgbClr val="EBEBEB"/>
             </a:solidFill>
@@ -42157,7 +42157,7 @@
             <a:avLst/>
           </a:prstGeom>
           <a:noFill/>
-          <a:ln>
+          <a:ln w="12700">
             <a:solidFill>
               <a:srgbClr val="EBEBEB"/>
             </a:solidFill>
@@ -42340,7 +42340,7 @@
             <a:avLst/>
           </a:prstGeom>
           <a:noFill/>
-          <a:ln>
+          <a:ln w="12700">
             <a:solidFill>
               <a:srgbClr val="EBEBEB"/>
             </a:solidFill>
@@ -42558,7 +42558,7 @@
             <a:avLst/>
           </a:prstGeom>
           <a:noFill/>
-          <a:ln>
+          <a:ln w="12700">
             <a:solidFill>
               <a:srgbClr val="EBEBEB"/>
             </a:solidFill>
@@ -42916,7 +42916,7 @@
             <a:avLst/>
           </a:prstGeom>
           <a:noFill/>
-          <a:ln>
+          <a:ln w="12700">
             <a:solidFill>
               <a:srgbClr val="EBEBEB"/>
             </a:solidFill>
@@ -43134,7 +43134,7 @@
             <a:avLst/>
           </a:prstGeom>
           <a:noFill/>
-          <a:ln>
+          <a:ln w="12700">
             <a:solidFill>
               <a:srgbClr val="EBEBEB"/>
             </a:solidFill>
@@ -43305,7 +43305,7 @@
             <a:avLst/>
           </a:prstGeom>
           <a:noFill/>
-          <a:ln>
+          <a:ln w="12700">
             <a:solidFill>
               <a:srgbClr val="EBEBEB"/>
             </a:solidFill>
@@ -43733,7 +43733,7 @@
             <a:avLst/>
           </a:prstGeom>
           <a:noFill/>
-          <a:ln>
+          <a:ln w="12700">
             <a:solidFill>
               <a:srgbClr val="EBEBEB"/>
             </a:solidFill>
@@ -43881,7 +43881,7 @@
             <a:avLst/>
           </a:prstGeom>
           <a:noFill/>
-          <a:ln>
+          <a:ln w="12700">
             <a:solidFill>
               <a:srgbClr val="EBEBEB"/>
             </a:solidFill>
@@ -44029,7 +44029,7 @@
             <a:avLst/>
           </a:prstGeom>
           <a:noFill/>
-          <a:ln>
+          <a:ln w="12700">
             <a:solidFill>
               <a:srgbClr val="EBEBEB"/>
             </a:solidFill>
@@ -44177,7 +44177,7 @@
             <a:avLst/>
           </a:prstGeom>
           <a:noFill/>
-          <a:ln>
+          <a:ln w="12700">
             <a:solidFill>
               <a:srgbClr val="EBEBEB"/>
             </a:solidFill>
@@ -44605,7 +44605,7 @@
             <a:avLst/>
           </a:prstGeom>
           <a:noFill/>
-          <a:ln>
+          <a:ln w="12700">
             <a:solidFill>
               <a:srgbClr val="EBEBEB"/>
             </a:solidFill>
@@ -44916,7 +44916,7 @@
             <a:avLst/>
           </a:prstGeom>
           <a:noFill/>
-          <a:ln>
+          <a:ln w="12700">
             <a:solidFill>
               <a:srgbClr val="EBEBEB"/>
             </a:solidFill>
@@ -45134,7 +45134,7 @@
             <a:avLst/>
           </a:prstGeom>
           <a:noFill/>
-          <a:ln>
+          <a:ln w="12700">
             <a:solidFill>
               <a:srgbClr val="EBEBEB"/>
             </a:solidFill>
@@ -45352,7 +45352,7 @@
             <a:avLst/>
           </a:prstGeom>
           <a:noFill/>
-          <a:ln>
+          <a:ln w="12700">
             <a:solidFill>
               <a:srgbClr val="EBEBEB"/>
             </a:solidFill>
@@ -45570,7 +45570,7 @@
             <a:avLst/>
           </a:prstGeom>
           <a:noFill/>
-          <a:ln>
+          <a:ln w="12700">
             <a:solidFill>
               <a:srgbClr val="EBEBEB"/>
             </a:solidFill>
@@ -45788,7 +45788,7 @@
             <a:avLst/>
           </a:prstGeom>
           <a:noFill/>
-          <a:ln>
+          <a:ln w="12700">
             <a:solidFill>
               <a:srgbClr val="EBEBEB"/>
             </a:solidFill>
@@ -46006,7 +46006,7 @@
             <a:avLst/>
           </a:prstGeom>
           <a:noFill/>
-          <a:ln>
+          <a:ln w="12700">
             <a:solidFill>
               <a:srgbClr val="EBEBEB"/>
             </a:solidFill>
@@ -46224,7 +46224,7 @@
             <a:avLst/>
           </a:prstGeom>
           <a:noFill/>
-          <a:ln>
+          <a:ln w="12700">
             <a:solidFill>
               <a:srgbClr val="EBEBEB"/>
             </a:solidFill>
@@ -46535,7 +46535,7 @@
             <a:avLst/>
           </a:prstGeom>
           <a:noFill/>
-          <a:ln>
+          <a:ln w="12700">
             <a:solidFill>
               <a:srgbClr val="EBEBEB"/>
             </a:solidFill>
@@ -46788,7 +46788,7 @@
             <a:avLst/>
           </a:prstGeom>
           <a:noFill/>
-          <a:ln>
+          <a:ln w="12700">
             <a:solidFill>
               <a:srgbClr val="EBEBEB"/>
             </a:solidFill>
@@ -47041,7 +47041,7 @@
             <a:avLst/>
           </a:prstGeom>
           <a:noFill/>
-          <a:ln>
+          <a:ln w="12700">
             <a:solidFill>
               <a:srgbClr val="EBEBEB"/>
             </a:solidFill>
@@ -47259,7 +47259,7 @@
             <a:avLst/>
           </a:prstGeom>
           <a:noFill/>
-          <a:ln>
+          <a:ln w="12700">
             <a:solidFill>
               <a:srgbClr val="EBEBEB"/>
             </a:solidFill>
@@ -47337,7 +47337,7 @@
             <a:avLst/>
           </a:prstGeom>
           <a:noFill/>
-          <a:ln>
+          <a:ln w="12700">
             <a:solidFill>
               <a:srgbClr val="EBEBEB"/>
             </a:solidFill>
@@ -47555,7 +47555,7 @@
             <a:avLst/>
           </a:prstGeom>
           <a:noFill/>
-          <a:ln>
+          <a:ln w="12700">
             <a:solidFill>
               <a:srgbClr val="EBEBEB"/>
             </a:solidFill>
@@ -47808,7 +47808,7 @@
             <a:avLst/>
           </a:prstGeom>
           <a:noFill/>
-          <a:ln>
+          <a:ln w="12700">
             <a:solidFill>
               <a:srgbClr val="EBEBEB"/>
             </a:solidFill>
@@ -48119,7 +48119,7 @@
             <a:avLst/>
           </a:prstGeom>
           <a:noFill/>
-          <a:ln>
+          <a:ln w="12700">
             <a:solidFill>
               <a:srgbClr val="EBEBEB"/>
             </a:solidFill>
@@ -48337,7 +48337,7 @@
             <a:avLst/>
           </a:prstGeom>
           <a:noFill/>
-          <a:ln>
+          <a:ln w="12700">
             <a:solidFill>
               <a:srgbClr val="EBEBEB"/>
             </a:solidFill>
@@ -48450,7 +48450,7 @@
             <a:avLst/>
           </a:prstGeom>
           <a:noFill/>
-          <a:ln>
+          <a:ln w="12700">
             <a:solidFill>
               <a:srgbClr val="EBEBEB"/>
             </a:solidFill>
@@ -48668,7 +48668,7 @@
             <a:avLst/>
           </a:prstGeom>
           <a:noFill/>
-          <a:ln>
+          <a:ln w="12700">
             <a:solidFill>
               <a:srgbClr val="EBEBEB"/>
             </a:solidFill>
@@ -48781,7 +48781,7 @@
             <a:avLst/>
           </a:prstGeom>
           <a:noFill/>
-          <a:ln>
+          <a:ln w="12700">
             <a:solidFill>
               <a:srgbClr val="EBEBEB"/>
             </a:solidFill>
@@ -48999,7 +48999,7 @@
             <a:avLst/>
           </a:prstGeom>
           <a:noFill/>
-          <a:ln>
+          <a:ln w="12700">
             <a:solidFill>
               <a:srgbClr val="EBEBEB"/>
             </a:solidFill>
@@ -49287,7 +49287,7 @@
             <a:avLst/>
           </a:prstGeom>
           <a:noFill/>
-          <a:ln>
+          <a:ln w="12700">
             <a:solidFill>
               <a:srgbClr val="EBEBEB"/>
             </a:solidFill>

</xml_diff>